<commit_message>
update DP-gram spec per implementation
</commit_message>
<xml_diff>
--- a/Specifications/dpgram/GUI-Screens.pptx
+++ b/Specifications/dpgram/GUI-Screens.pptx
@@ -261,7 +261,7 @@
           <a:p>
             <a:fld id="{6E783203-F72E-42D3-9F56-E7123AD26E23}" type="datetimeFigureOut">
               <a:rPr lang="en-US" smtClean="0"/>
-              <a:t>8/7/2026</a:t>
+              <a:t>8/19/2026</a:t>
             </a:fld>
             <a:endParaRPr lang="en-US"/>
           </a:p>
@@ -459,7 +459,7 @@
           <a:p>
             <a:fld id="{6E783203-F72E-42D3-9F56-E7123AD26E23}" type="datetimeFigureOut">
               <a:rPr lang="en-US" smtClean="0"/>
-              <a:t>8/7/2026</a:t>
+              <a:t>8/19/2026</a:t>
             </a:fld>
             <a:endParaRPr lang="en-US"/>
           </a:p>
@@ -667,7 +667,7 @@
           <a:p>
             <a:fld id="{6E783203-F72E-42D3-9F56-E7123AD26E23}" type="datetimeFigureOut">
               <a:rPr lang="en-US" smtClean="0"/>
-              <a:t>8/7/2026</a:t>
+              <a:t>8/19/2026</a:t>
             </a:fld>
             <a:endParaRPr lang="en-US"/>
           </a:p>
@@ -865,7 +865,7 @@
           <a:p>
             <a:fld id="{6E783203-F72E-42D3-9F56-E7123AD26E23}" type="datetimeFigureOut">
               <a:rPr lang="en-US" smtClean="0"/>
-              <a:t>8/7/2026</a:t>
+              <a:t>8/19/2026</a:t>
             </a:fld>
             <a:endParaRPr lang="en-US"/>
           </a:p>
@@ -1140,7 +1140,7 @@
           <a:p>
             <a:fld id="{6E783203-F72E-42D3-9F56-E7123AD26E23}" type="datetimeFigureOut">
               <a:rPr lang="en-US" smtClean="0"/>
-              <a:t>8/7/2026</a:t>
+              <a:t>8/19/2026</a:t>
             </a:fld>
             <a:endParaRPr lang="en-US"/>
           </a:p>
@@ -1405,7 +1405,7 @@
           <a:p>
             <a:fld id="{6E783203-F72E-42D3-9F56-E7123AD26E23}" type="datetimeFigureOut">
               <a:rPr lang="en-US" smtClean="0"/>
-              <a:t>8/7/2026</a:t>
+              <a:t>8/19/2026</a:t>
             </a:fld>
             <a:endParaRPr lang="en-US"/>
           </a:p>
@@ -1817,7 +1817,7 @@
           <a:p>
             <a:fld id="{6E783203-F72E-42D3-9F56-E7123AD26E23}" type="datetimeFigureOut">
               <a:rPr lang="en-US" smtClean="0"/>
-              <a:t>8/7/2026</a:t>
+              <a:t>8/19/2026</a:t>
             </a:fld>
             <a:endParaRPr lang="en-US"/>
           </a:p>
@@ -1958,7 +1958,7 @@
           <a:p>
             <a:fld id="{6E783203-F72E-42D3-9F56-E7123AD26E23}" type="datetimeFigureOut">
               <a:rPr lang="en-US" smtClean="0"/>
-              <a:t>8/7/2026</a:t>
+              <a:t>8/19/2026</a:t>
             </a:fld>
             <a:endParaRPr lang="en-US"/>
           </a:p>
@@ -2071,7 +2071,7 @@
           <a:p>
             <a:fld id="{6E783203-F72E-42D3-9F56-E7123AD26E23}" type="datetimeFigureOut">
               <a:rPr lang="en-US" smtClean="0"/>
-              <a:t>8/7/2026</a:t>
+              <a:t>8/19/2026</a:t>
             </a:fld>
             <a:endParaRPr lang="en-US"/>
           </a:p>
@@ -2382,7 +2382,7 @@
           <a:p>
             <a:fld id="{6E783203-F72E-42D3-9F56-E7123AD26E23}" type="datetimeFigureOut">
               <a:rPr lang="en-US" smtClean="0"/>
-              <a:t>8/7/2026</a:t>
+              <a:t>8/19/2026</a:t>
             </a:fld>
             <a:endParaRPr lang="en-US"/>
           </a:p>
@@ -2670,7 +2670,7 @@
           <a:p>
             <a:fld id="{6E783203-F72E-42D3-9F56-E7123AD26E23}" type="datetimeFigureOut">
               <a:rPr lang="en-US" smtClean="0"/>
-              <a:t>8/7/2026</a:t>
+              <a:t>8/19/2026</a:t>
             </a:fld>
             <a:endParaRPr lang="en-US"/>
           </a:p>
@@ -2911,7 +2911,7 @@
           <a:p>
             <a:fld id="{6E783203-F72E-42D3-9F56-E7123AD26E23}" type="datetimeFigureOut">
               <a:rPr lang="en-US" smtClean="0"/>
-              <a:t>8/7/2026</a:t>
+              <a:t>8/19/2026</a:t>
             </a:fld>
             <a:endParaRPr lang="en-US"/>
           </a:p>
@@ -3686,7 +3686,7 @@
                     <a:ea typeface="+mn-ea"/>
                     <a:cs typeface="+mn-cs"/>
                   </a:rPr>
-                  <a:t>Title: “DPGRAM” </a:t>
+                  <a:t>Title: “DP-gram” </a:t>
                 </a:r>
                 <a:endParaRPr lang="en-US" b="1" dirty="0"/>
               </a:p>
@@ -3826,14 +3826,14 @@
           <p:nvPr>
             <p:extLst>
               <p:ext uri="{D42A27DB-BD31-4B8C-83A1-F6EECF244321}">
-                <p14:modId xmlns:p14="http://schemas.microsoft.com/office/powerpoint/2010/main" val="2845407314"/>
+                <p14:modId xmlns:p14="http://schemas.microsoft.com/office/powerpoint/2010/main" val="3597752681"/>
               </p:ext>
             </p:extLst>
           </p:nvPr>
         </p:nvGraphicFramePr>
         <p:xfrm>
           <a:off x="3678348" y="1422249"/>
-          <a:ext cx="4795974" cy="2438400"/>
+          <a:ext cx="4795974" cy="1828800"/>
         </p:xfrm>
         <a:graphic>
           <a:graphicData uri="http://schemas.openxmlformats.org/drawingml/2006/table">
@@ -3930,7 +3930,7 @@
                             </a:schemeClr>
                           </a:solidFill>
                         </a:rPr>
-                        <a:t>Frequency Array [ Hz[] ]</a:t>
+                        <a:t>F2 Frequencies [Hz]</a:t>
                       </a:r>
                     </a:p>
                   </a:txBody>
@@ -4064,7 +4064,7 @@
                             </a:schemeClr>
                           </a:solidFill>
                         </a:rPr>
-                        <a:t>Sweep Duration [s]</a:t>
+                        <a:t>L1 [dB]</a:t>
                       </a:r>
                     </a:p>
                   </a:txBody>
@@ -4121,7 +4121,7 @@
                             </a:schemeClr>
                           </a:solidFill>
                         </a:rPr>
-                        <a:t>Window Duration [s]</a:t>
+                        <a:t>L2 [dB]</a:t>
                       </a:r>
                     </a:p>
                   </a:txBody>
@@ -4161,120 +4161,6 @@
                 <a:extLst>
                   <a:ext uri="{0D108BD9-81ED-4DB2-BD59-A6C34878D82A}">
                     <a16:rowId xmlns:a16="http://schemas.microsoft.com/office/drawing/2014/main" val="328923842"/>
-                  </a:ext>
-                </a:extLst>
-              </a:tr>
-              <a:tr h="281251">
-                <a:tc>
-                  <a:txBody>
-                    <a:bodyPr/>
-                    <a:lstStyle/>
-                    <a:p>
-                      <a:r>
-                        <a:rPr lang="en-US" sz="1400" dirty="0">
-                          <a:solidFill>
-                            <a:schemeClr val="bg2">
-                              <a:lumMod val="25000"/>
-                            </a:schemeClr>
-                          </a:solidFill>
-                        </a:rPr>
-                        <a:t>Minimum Num Sweeps</a:t>
-                      </a:r>
-                    </a:p>
-                  </a:txBody>
-                  <a:tcPr>
-                    <a:solidFill>
-                      <a:schemeClr val="bg1">
-                        <a:lumMod val="85000"/>
-                      </a:schemeClr>
-                    </a:solidFill>
-                  </a:tcPr>
-                </a:tc>
-                <a:tc>
-                  <a:txBody>
-                    <a:bodyPr/>
-                    <a:lstStyle/>
-                    <a:p>
-                      <a:r>
-                        <a:rPr lang="en-US" sz="1400" dirty="0">
-                          <a:solidFill>
-                            <a:schemeClr val="bg2">
-                              <a:lumMod val="25000"/>
-                            </a:schemeClr>
-                          </a:solidFill>
-                        </a:rPr>
-                        <a:t>[MinSweeps]</a:t>
-                      </a:r>
-                    </a:p>
-                  </a:txBody>
-                  <a:tcPr>
-                    <a:solidFill>
-                      <a:schemeClr val="bg1">
-                        <a:lumMod val="85000"/>
-                      </a:schemeClr>
-                    </a:solidFill>
-                  </a:tcPr>
-                </a:tc>
-                <a:extLst>
-                  <a:ext uri="{0D108BD9-81ED-4DB2-BD59-A6C34878D82A}">
-                    <a16:rowId xmlns:a16="http://schemas.microsoft.com/office/drawing/2014/main" val="2397434598"/>
-                  </a:ext>
-                </a:extLst>
-              </a:tr>
-              <a:tr h="281251">
-                <a:tc>
-                  <a:txBody>
-                    <a:bodyPr/>
-                    <a:lstStyle/>
-                    <a:p>
-                      <a:r>
-                        <a:rPr lang="en-US" sz="1400" dirty="0">
-                          <a:solidFill>
-                            <a:schemeClr val="bg2">
-                              <a:lumMod val="25000"/>
-                            </a:schemeClr>
-                          </a:solidFill>
-                        </a:rPr>
-                        <a:t>Maximum Num Sweeps</a:t>
-                      </a:r>
-                    </a:p>
-                  </a:txBody>
-                  <a:tcPr>
-                    <a:solidFill>
-                      <a:schemeClr val="bg1">
-                        <a:lumMod val="85000"/>
-                      </a:schemeClr>
-                    </a:solidFill>
-                  </a:tcPr>
-                </a:tc>
-                <a:tc>
-                  <a:txBody>
-                    <a:bodyPr/>
-                    <a:lstStyle/>
-                    <a:p>
-                      <a:r>
-                        <a:rPr lang="en-US" sz="1400" dirty="0">
-                          <a:solidFill>
-                            <a:schemeClr val="bg2">
-                              <a:lumMod val="25000"/>
-                            </a:schemeClr>
-                          </a:solidFill>
-                        </a:rPr>
-                        <a:t>[MaxSweeps]</a:t>
-                      </a:r>
-                    </a:p>
-                  </a:txBody>
-                  <a:tcPr>
-                    <a:solidFill>
-                      <a:schemeClr val="bg1">
-                        <a:lumMod val="85000"/>
-                      </a:schemeClr>
-                    </a:solidFill>
-                  </a:tcPr>
-                </a:tc>
-                <a:extLst>
-                  <a:ext uri="{0D108BD9-81ED-4DB2-BD59-A6C34878D82A}">
-                    <a16:rowId xmlns:a16="http://schemas.microsoft.com/office/drawing/2014/main" val="3148996428"/>
                   </a:ext>
                 </a:extLst>
               </a:tr>
@@ -4397,9 +4283,9 @@
         </p:nvGrpSpPr>
         <p:grpSpPr>
           <a:xfrm>
-            <a:off x="3142442" y="120445"/>
+            <a:off x="2940407" y="-198782"/>
             <a:ext cx="5867785" cy="6617110"/>
-            <a:chOff x="3142442" y="120445"/>
+            <a:chOff x="3090235" y="120445"/>
             <a:chExt cx="5867785" cy="6617110"/>
           </a:xfrm>
         </p:grpSpPr>
@@ -4417,9 +4303,9 @@
           </p:nvGrpSpPr>
           <p:grpSpPr>
             <a:xfrm>
-              <a:off x="3142442" y="120445"/>
+              <a:off x="3090235" y="120445"/>
               <a:ext cx="5867785" cy="6617110"/>
-              <a:chOff x="3142601" y="108155"/>
+              <a:chOff x="3090394" y="108155"/>
               <a:chExt cx="5867785" cy="6617110"/>
             </a:xfrm>
           </p:grpSpPr>
@@ -4489,9 +4375,9 @@
             </p:nvGrpSpPr>
             <p:grpSpPr>
               <a:xfrm>
-                <a:off x="3142601" y="108155"/>
+                <a:off x="3090394" y="108155"/>
                 <a:ext cx="5867785" cy="6617110"/>
-                <a:chOff x="3142601" y="108155"/>
+                <a:chOff x="3090394" y="108155"/>
                 <a:chExt cx="5867785" cy="6617110"/>
               </a:xfrm>
             </p:grpSpPr>
@@ -4602,7 +4488,7 @@
               </p:nvSpPr>
               <p:spPr>
                 <a:xfrm>
-                  <a:off x="3142601" y="108155"/>
+                  <a:off x="3090394" y="108155"/>
                   <a:ext cx="5867785" cy="6617110"/>
                 </a:xfrm>
                 <a:prstGeom prst="rect">
@@ -4732,7 +4618,7 @@
                       <a:ea typeface="+mn-ea"/>
                       <a:cs typeface="+mn-cs"/>
                     </a:rPr>
-                    <a:t>Title: “DPGRAM” </a:t>
+                    <a:t>Title: “DP-gram” </a:t>
                   </a:r>
                   <a:endParaRPr lang="en-US" b="1" dirty="0"/>
                 </a:p>
@@ -5056,151 +4942,6 @@
             </a:p>
           </p:txBody>
         </p:sp>
-        <p:pic>
-          <p:nvPicPr>
-            <p:cNvPr id="17" name="Picture 16">
-              <a:extLst>
-                <a:ext uri="{FF2B5EF4-FFF2-40B4-BE49-F238E27FC236}">
-                  <a16:creationId xmlns:a16="http://schemas.microsoft.com/office/drawing/2014/main" id="{896BA1FF-F271-64E6-68D6-A07375F18B62}"/>
-                </a:ext>
-              </a:extLst>
-            </p:cNvPr>
-            <p:cNvPicPr>
-              <a:picLocks noChangeAspect="1"/>
-            </p:cNvPicPr>
-            <p:nvPr/>
-          </p:nvPicPr>
-          <p:blipFill>
-            <a:blip r:embed="rId4">
-              <a:extLst>
-                <a:ext uri="{28A0092B-C50C-407E-A947-70E740481C1C}">
-                  <a14:useLocalDpi xmlns:a14="http://schemas.microsoft.com/office/drawing/2010/main" val="0"/>
-                </a:ext>
-              </a:extLst>
-            </a:blip>
-            <a:srcRect l="575" t="21456" r="6284" b="447"/>
-            <a:stretch/>
-          </p:blipFill>
-          <p:spPr>
-            <a:xfrm>
-              <a:off x="4039468" y="1491716"/>
-              <a:ext cx="3957220" cy="2987416"/>
-            </a:xfrm>
-            <a:prstGeom prst="rect">
-              <a:avLst/>
-            </a:prstGeom>
-            <a:ln>
-              <a:solidFill>
-                <a:schemeClr val="tx1"/>
-              </a:solidFill>
-            </a:ln>
-          </p:spPr>
-        </p:pic>
-        <p:sp>
-          <p:nvSpPr>
-            <p:cNvPr id="13" name="Rectangle 12">
-              <a:extLst>
-                <a:ext uri="{FF2B5EF4-FFF2-40B4-BE49-F238E27FC236}">
-                  <a16:creationId xmlns:a16="http://schemas.microsoft.com/office/drawing/2014/main" id="{2565031A-1428-14DC-3301-DAAEC6E27F92}"/>
-                </a:ext>
-              </a:extLst>
-            </p:cNvPr>
-            <p:cNvSpPr/>
-            <p:nvPr/>
-          </p:nvSpPr>
-          <p:spPr>
-            <a:xfrm>
-              <a:off x="6600074" y="1594980"/>
-              <a:ext cx="1196282" cy="640483"/>
-            </a:xfrm>
-            <a:prstGeom prst="rect">
-              <a:avLst/>
-            </a:prstGeom>
-            <a:solidFill>
-              <a:schemeClr val="bg1"/>
-            </a:solidFill>
-            <a:ln>
-              <a:solidFill>
-                <a:schemeClr val="bg1">
-                  <a:lumMod val="75000"/>
-                </a:schemeClr>
-              </a:solidFill>
-            </a:ln>
-          </p:spPr>
-          <p:style>
-            <a:lnRef idx="2">
-              <a:schemeClr val="accent1">
-                <a:shade val="15000"/>
-              </a:schemeClr>
-            </a:lnRef>
-            <a:fillRef idx="1">
-              <a:schemeClr val="accent1"/>
-            </a:fillRef>
-            <a:effectRef idx="0">
-              <a:schemeClr val="accent1"/>
-            </a:effectRef>
-            <a:fontRef idx="minor">
-              <a:schemeClr val="lt1"/>
-            </a:fontRef>
-          </p:style>
-          <p:txBody>
-            <a:bodyPr rtlCol="0" anchor="ctr"/>
-            <a:lstStyle/>
-            <a:p>
-              <a:r>
-                <a:rPr lang="en-US" sz="900" b="1" dirty="0">
-                  <a:solidFill>
-                    <a:srgbClr val="0070C0"/>
-                  </a:solidFill>
-                </a:rPr>
-                <a:t>O          </a:t>
-              </a:r>
-              <a:r>
-                <a:rPr lang="en-US" sz="900" b="1" dirty="0">
-                  <a:solidFill>
-                    <a:schemeClr val="tx1"/>
-                  </a:solidFill>
-                </a:rPr>
-                <a:t>DPOAE</a:t>
-              </a:r>
-              <a:endParaRPr lang="en-US" sz="900" b="1" dirty="0">
-                <a:solidFill>
-                  <a:srgbClr val="0070C0"/>
-                </a:solidFill>
-              </a:endParaRPr>
-            </a:p>
-            <a:p>
-              <a:endParaRPr lang="en-US" sz="900" dirty="0">
-                <a:solidFill>
-                  <a:srgbClr val="0070C0"/>
-                </a:solidFill>
-              </a:endParaRPr>
-            </a:p>
-            <a:p>
-              <a:r>
-                <a:rPr lang="en-US" sz="900" b="1" dirty="0">
-                  <a:solidFill>
-                    <a:srgbClr val="C00000"/>
-                  </a:solidFill>
-                </a:rPr>
-                <a:t>X          </a:t>
-              </a:r>
-              <a:r>
-                <a:rPr lang="en-US" sz="900" b="1" dirty="0">
-                  <a:solidFill>
-                    <a:schemeClr val="tx1"/>
-                  </a:solidFill>
-                </a:rPr>
-                <a:t>NOISE</a:t>
-              </a:r>
-              <a:endParaRPr lang="en-US" sz="900" b="1" dirty="0">
-                <a:solidFill>
-                  <a:srgbClr val="C00000"/>
-                </a:solidFill>
-              </a:endParaRPr>
-            </a:p>
-          </p:txBody>
-        </p:sp>
         <p:sp>
           <p:nvSpPr>
             <p:cNvPr id="15" name="Rectangle 14">
@@ -5309,405 +5050,38 @@
             </a:p>
           </p:txBody>
         </p:sp>
-        <p:pic>
-          <p:nvPicPr>
-            <p:cNvPr id="23" name="Picture 22">
-              <a:extLst>
-                <a:ext uri="{FF2B5EF4-FFF2-40B4-BE49-F238E27FC236}">
-                  <a16:creationId xmlns:a16="http://schemas.microsoft.com/office/drawing/2014/main" id="{8361E361-0E6C-37E7-B2B8-5EA6CA751E99}"/>
-                </a:ext>
-              </a:extLst>
-            </p:cNvPr>
-            <p:cNvPicPr>
-              <a:picLocks noChangeAspect="1"/>
-            </p:cNvPicPr>
-            <p:nvPr/>
-          </p:nvPicPr>
-          <p:blipFill>
-            <a:blip r:embed="rId5"/>
-            <a:stretch>
-              <a:fillRect/>
-            </a:stretch>
-          </p:blipFill>
-          <p:spPr>
-            <a:xfrm>
-              <a:off x="4079202" y="2074887"/>
-              <a:ext cx="261668" cy="1626079"/>
-            </a:xfrm>
-            <a:prstGeom prst="rect">
-              <a:avLst/>
-            </a:prstGeom>
-          </p:spPr>
-        </p:pic>
-        <p:cxnSp>
-          <p:nvCxnSpPr>
-            <p:cNvPr id="27" name="Straight Connector 26">
-              <a:extLst>
-                <a:ext uri="{FF2B5EF4-FFF2-40B4-BE49-F238E27FC236}">
-                  <a16:creationId xmlns:a16="http://schemas.microsoft.com/office/drawing/2014/main" id="{4CED889C-5D23-2D61-E3A7-E444720AB004}"/>
-                </a:ext>
-              </a:extLst>
-            </p:cNvPr>
-            <p:cNvCxnSpPr/>
-            <p:nvPr/>
-          </p:nvCxnSpPr>
-          <p:spPr>
-            <a:xfrm flipH="1">
-              <a:off x="6359097" y="4479132"/>
-              <a:ext cx="895718" cy="0"/>
-            </a:xfrm>
-            <a:prstGeom prst="line">
-              <a:avLst/>
-            </a:prstGeom>
-            <a:ln w="12700"/>
-          </p:spPr>
-          <p:style>
-            <a:lnRef idx="2">
-              <a:schemeClr val="dk1"/>
-            </a:lnRef>
-            <a:fillRef idx="0">
-              <a:schemeClr val="dk1"/>
-            </a:fillRef>
-            <a:effectRef idx="1">
-              <a:schemeClr val="dk1"/>
-            </a:effectRef>
-            <a:fontRef idx="minor">
-              <a:schemeClr val="tx1"/>
-            </a:fontRef>
-          </p:style>
-        </p:cxnSp>
-        <p:sp>
-          <p:nvSpPr>
-            <p:cNvPr id="29" name="Rectangle 28">
-              <a:extLst>
-                <a:ext uri="{FF2B5EF4-FFF2-40B4-BE49-F238E27FC236}">
-                  <a16:creationId xmlns:a16="http://schemas.microsoft.com/office/drawing/2014/main" id="{74590467-BED6-E84D-8D50-960D991E4977}"/>
-                </a:ext>
-              </a:extLst>
-            </p:cNvPr>
-            <p:cNvSpPr/>
-            <p:nvPr/>
-          </p:nvSpPr>
-          <p:spPr>
-            <a:xfrm>
-              <a:off x="4364968" y="4123426"/>
-              <a:ext cx="3588590" cy="141512"/>
-            </a:xfrm>
-            <a:prstGeom prst="rect">
-              <a:avLst/>
-            </a:prstGeom>
-            <a:solidFill>
-              <a:schemeClr val="bg1"/>
-            </a:solidFill>
-            <a:ln>
-              <a:solidFill>
-                <a:schemeClr val="bg1"/>
-              </a:solidFill>
-            </a:ln>
-          </p:spPr>
-          <p:style>
-            <a:lnRef idx="2">
-              <a:schemeClr val="accent1">
-                <a:shade val="15000"/>
-              </a:schemeClr>
-            </a:lnRef>
-            <a:fillRef idx="1">
-              <a:schemeClr val="accent1"/>
-            </a:fillRef>
-            <a:effectRef idx="0">
-              <a:schemeClr val="accent1"/>
-            </a:effectRef>
-            <a:fontRef idx="minor">
-              <a:schemeClr val="lt1"/>
-            </a:fontRef>
-          </p:style>
-          <p:txBody>
-            <a:bodyPr rtlCol="0" anchor="ctr"/>
-            <a:lstStyle/>
-            <a:p>
-              <a:pPr algn="ctr"/>
-              <a:endParaRPr lang="en-US"/>
-            </a:p>
-          </p:txBody>
-        </p:sp>
-        <p:sp>
-          <p:nvSpPr>
-            <p:cNvPr id="28" name="TextBox 27">
-              <a:extLst>
-                <a:ext uri="{FF2B5EF4-FFF2-40B4-BE49-F238E27FC236}">
-                  <a16:creationId xmlns:a16="http://schemas.microsoft.com/office/drawing/2014/main" id="{F7F157F4-28D8-2958-B2F2-49C6F4D5E7B8}"/>
-                </a:ext>
-              </a:extLst>
-            </p:cNvPr>
-            <p:cNvSpPr txBox="1"/>
-            <p:nvPr/>
-          </p:nvSpPr>
-          <p:spPr>
-            <a:xfrm>
-              <a:off x="4365599" y="4086718"/>
-              <a:ext cx="489922" cy="261610"/>
-            </a:xfrm>
-            <a:prstGeom prst="rect">
-              <a:avLst/>
-            </a:prstGeom>
-            <a:noFill/>
-          </p:spPr>
-          <p:txBody>
-            <a:bodyPr wrap="square" rtlCol="0">
-              <a:spAutoFit/>
-            </a:bodyPr>
-            <a:lstStyle/>
-            <a:p>
-              <a:r>
-                <a:rPr lang="en-US" sz="1100" dirty="0">
-                  <a:latin typeface="+mj-lt"/>
-                </a:rPr>
-                <a:t>500</a:t>
-              </a:r>
-              <a:endParaRPr lang="en-US" sz="1050" dirty="0">
-                <a:latin typeface="+mj-lt"/>
-              </a:endParaRPr>
-            </a:p>
-          </p:txBody>
-        </p:sp>
-        <p:sp>
-          <p:nvSpPr>
-            <p:cNvPr id="30" name="TextBox 29">
-              <a:extLst>
-                <a:ext uri="{FF2B5EF4-FFF2-40B4-BE49-F238E27FC236}">
-                  <a16:creationId xmlns:a16="http://schemas.microsoft.com/office/drawing/2014/main" id="{E009F830-5BEE-5093-48C6-73D6C67ECF9F}"/>
-                </a:ext>
-              </a:extLst>
-            </p:cNvPr>
-            <p:cNvSpPr txBox="1"/>
-            <p:nvPr/>
-          </p:nvSpPr>
-          <p:spPr>
-            <a:xfrm>
-              <a:off x="5063783" y="4061128"/>
-              <a:ext cx="348519" cy="261610"/>
-            </a:xfrm>
-            <a:prstGeom prst="rect">
-              <a:avLst/>
-            </a:prstGeom>
-            <a:noFill/>
-          </p:spPr>
-          <p:txBody>
-            <a:bodyPr wrap="square" rtlCol="0">
-              <a:spAutoFit/>
-            </a:bodyPr>
-            <a:lstStyle/>
-            <a:p>
-              <a:r>
-                <a:rPr lang="en-US" sz="1100" dirty="0">
-                  <a:latin typeface="+mj-lt"/>
-                </a:rPr>
-                <a:t>1k</a:t>
-              </a:r>
-              <a:endParaRPr lang="en-US" sz="1050" dirty="0">
-                <a:latin typeface="+mj-lt"/>
-              </a:endParaRPr>
-            </a:p>
-          </p:txBody>
-        </p:sp>
-        <p:sp>
-          <p:nvSpPr>
-            <p:cNvPr id="31" name="TextBox 30">
-              <a:extLst>
-                <a:ext uri="{FF2B5EF4-FFF2-40B4-BE49-F238E27FC236}">
-                  <a16:creationId xmlns:a16="http://schemas.microsoft.com/office/drawing/2014/main" id="{1E02A35B-CDC0-081F-4389-A6AB755922B3}"/>
-                </a:ext>
-              </a:extLst>
-            </p:cNvPr>
-            <p:cNvSpPr txBox="1"/>
-            <p:nvPr/>
-          </p:nvSpPr>
-          <p:spPr>
-            <a:xfrm>
-              <a:off x="5719581" y="4060249"/>
-              <a:ext cx="382006" cy="261610"/>
-            </a:xfrm>
-            <a:prstGeom prst="rect">
-              <a:avLst/>
-            </a:prstGeom>
-            <a:noFill/>
-          </p:spPr>
-          <p:txBody>
-            <a:bodyPr wrap="square" rtlCol="0">
-              <a:spAutoFit/>
-            </a:bodyPr>
-            <a:lstStyle/>
-            <a:p>
-              <a:r>
-                <a:rPr lang="en-US" sz="1100" dirty="0">
-                  <a:latin typeface="+mj-lt"/>
-                </a:rPr>
-                <a:t>2k</a:t>
-              </a:r>
-              <a:endParaRPr lang="en-US" sz="1050" dirty="0">
-                <a:latin typeface="+mj-lt"/>
-              </a:endParaRPr>
-            </a:p>
-          </p:txBody>
-        </p:sp>
-        <p:sp>
-          <p:nvSpPr>
-            <p:cNvPr id="32" name="TextBox 31">
-              <a:extLst>
-                <a:ext uri="{FF2B5EF4-FFF2-40B4-BE49-F238E27FC236}">
-                  <a16:creationId xmlns:a16="http://schemas.microsoft.com/office/drawing/2014/main" id="{F5068E25-AC7A-8F6B-3150-3FDA506ED7A1}"/>
-                </a:ext>
-              </a:extLst>
-            </p:cNvPr>
-            <p:cNvSpPr txBox="1"/>
-            <p:nvPr/>
-          </p:nvSpPr>
-          <p:spPr>
-            <a:xfrm>
-              <a:off x="6388315" y="4053135"/>
-              <a:ext cx="332693" cy="261610"/>
-            </a:xfrm>
-            <a:prstGeom prst="rect">
-              <a:avLst/>
-            </a:prstGeom>
-            <a:noFill/>
-          </p:spPr>
-          <p:txBody>
-            <a:bodyPr wrap="square" rtlCol="0">
-              <a:spAutoFit/>
-            </a:bodyPr>
-            <a:lstStyle/>
-            <a:p>
-              <a:r>
-                <a:rPr lang="en-US" sz="1100" dirty="0">
-                  <a:latin typeface="+mj-lt"/>
-                </a:rPr>
-                <a:t>4k</a:t>
-              </a:r>
-              <a:endParaRPr lang="en-US" sz="1050" dirty="0">
-                <a:latin typeface="+mj-lt"/>
-              </a:endParaRPr>
-            </a:p>
-          </p:txBody>
-        </p:sp>
-        <p:sp>
-          <p:nvSpPr>
-            <p:cNvPr id="33" name="TextBox 32">
-              <a:extLst>
-                <a:ext uri="{FF2B5EF4-FFF2-40B4-BE49-F238E27FC236}">
-                  <a16:creationId xmlns:a16="http://schemas.microsoft.com/office/drawing/2014/main" id="{8F5F8CDF-964A-629D-43BC-CAE9AF3B0564}"/>
-                </a:ext>
-              </a:extLst>
-            </p:cNvPr>
-            <p:cNvSpPr txBox="1"/>
-            <p:nvPr/>
-          </p:nvSpPr>
-          <p:spPr>
-            <a:xfrm>
-              <a:off x="7048672" y="4041732"/>
-              <a:ext cx="332693" cy="261610"/>
-            </a:xfrm>
-            <a:prstGeom prst="rect">
-              <a:avLst/>
-            </a:prstGeom>
-            <a:noFill/>
-          </p:spPr>
-          <p:txBody>
-            <a:bodyPr wrap="square" rtlCol="0">
-              <a:spAutoFit/>
-            </a:bodyPr>
-            <a:lstStyle/>
-            <a:p>
-              <a:r>
-                <a:rPr lang="en-US" sz="1100" dirty="0">
-                  <a:latin typeface="+mj-lt"/>
-                </a:rPr>
-                <a:t>8k</a:t>
-              </a:r>
-              <a:endParaRPr lang="en-US" sz="1050" dirty="0">
-                <a:latin typeface="+mj-lt"/>
-              </a:endParaRPr>
-            </a:p>
-          </p:txBody>
-        </p:sp>
-        <p:sp>
-          <p:nvSpPr>
-            <p:cNvPr id="34" name="TextBox 33">
-              <a:extLst>
-                <a:ext uri="{FF2B5EF4-FFF2-40B4-BE49-F238E27FC236}">
-                  <a16:creationId xmlns:a16="http://schemas.microsoft.com/office/drawing/2014/main" id="{A77E979E-FE15-9C62-9A29-D7FC14187514}"/>
-                </a:ext>
-              </a:extLst>
-            </p:cNvPr>
-            <p:cNvSpPr txBox="1"/>
-            <p:nvPr/>
-          </p:nvSpPr>
-          <p:spPr>
-            <a:xfrm>
-              <a:off x="7629461" y="4041732"/>
-              <a:ext cx="433971" cy="261610"/>
-            </a:xfrm>
-            <a:prstGeom prst="rect">
-              <a:avLst/>
-            </a:prstGeom>
-            <a:noFill/>
-          </p:spPr>
-          <p:txBody>
-            <a:bodyPr wrap="square" rtlCol="0">
-              <a:spAutoFit/>
-            </a:bodyPr>
-            <a:lstStyle/>
-            <a:p>
-              <a:r>
-                <a:rPr lang="en-US" sz="1100" dirty="0">
-                  <a:latin typeface="+mj-lt"/>
-                </a:rPr>
-                <a:t>16k</a:t>
-              </a:r>
-              <a:endParaRPr lang="en-US" sz="1050" dirty="0">
-                <a:latin typeface="+mj-lt"/>
-              </a:endParaRPr>
-            </a:p>
-          </p:txBody>
-        </p:sp>
-        <p:sp>
-          <p:nvSpPr>
-            <p:cNvPr id="19" name="TextBox 18">
-              <a:extLst>
-                <a:ext uri="{FF2B5EF4-FFF2-40B4-BE49-F238E27FC236}">
-                  <a16:creationId xmlns:a16="http://schemas.microsoft.com/office/drawing/2014/main" id="{9EC163EB-6A24-156D-1AEF-32E314BF12D5}"/>
-                </a:ext>
-              </a:extLst>
-            </p:cNvPr>
-            <p:cNvSpPr txBox="1"/>
-            <p:nvPr/>
-          </p:nvSpPr>
-          <p:spPr>
-            <a:xfrm>
-              <a:off x="5039419" y="4253209"/>
-              <a:ext cx="703911" cy="292388"/>
-            </a:xfrm>
-            <a:prstGeom prst="rect">
-              <a:avLst/>
-            </a:prstGeom>
-            <a:noFill/>
-          </p:spPr>
-          <p:txBody>
-            <a:bodyPr wrap="none" rtlCol="0">
-              <a:spAutoFit/>
-            </a:bodyPr>
-            <a:lstStyle/>
-            <a:p>
-              <a:r>
-                <a:rPr lang="en-US" sz="1300" dirty="0">
-                  <a:latin typeface="+mj-lt"/>
-                </a:rPr>
-                <a:t>DPOAE</a:t>
-              </a:r>
-            </a:p>
-          </p:txBody>
-        </p:sp>
       </p:grpSp>
+      <p:pic>
+        <p:nvPicPr>
+          <p:cNvPr id="21" name="Picture 20">
+            <a:extLst>
+              <a:ext uri="{FF2B5EF4-FFF2-40B4-BE49-F238E27FC236}">
+                <a16:creationId xmlns:a16="http://schemas.microsoft.com/office/drawing/2014/main" id="{EDB612F1-87AD-2D98-3026-A53187457ACD}"/>
+              </a:ext>
+            </a:extLst>
+          </p:cNvPr>
+          <p:cNvPicPr>
+            <a:picLocks noChangeAspect="1"/>
+          </p:cNvPicPr>
+          <p:nvPr/>
+        </p:nvPicPr>
+        <p:blipFill>
+          <a:blip r:embed="rId4"/>
+          <a:srcRect t="8143"/>
+          <a:stretch>
+            <a:fillRect/>
+          </a:stretch>
+        </p:blipFill>
+        <p:spPr>
+          <a:xfrm>
+            <a:off x="3634002" y="1283305"/>
+            <a:ext cx="4049067" cy="2789515"/>
+          </a:xfrm>
+          <a:prstGeom prst="rect">
+            <a:avLst/>
+          </a:prstGeom>
+        </p:spPr>
+      </p:pic>
     </p:spTree>
     <p:extLst>
       <p:ext uri="{BB962C8B-B14F-4D97-AF65-F5344CB8AC3E}">
@@ -5752,7 +5126,7 @@
         </p:nvGrpSpPr>
         <p:grpSpPr>
           <a:xfrm>
-            <a:off x="3162107" y="120445"/>
+            <a:off x="3162107" y="0"/>
             <a:ext cx="5867785" cy="6617110"/>
             <a:chOff x="3162107" y="120445"/>
             <a:chExt cx="5867785" cy="6617110"/>
@@ -6039,7 +5413,7 @@
                       <a:ea typeface="+mn-ea"/>
                       <a:cs typeface="+mn-cs"/>
                     </a:rPr>
-                    <a:t>Results: Swept DPOAE</a:t>
+                    <a:t>Results: DP-gram</a:t>
                   </a:r>
                   <a:endParaRPr lang="en-US" b="1" dirty="0"/>
                 </a:p>
@@ -6180,14 +5554,15 @@
           </p:nvPicPr>
           <p:blipFill>
             <a:blip r:embed="rId4"/>
+            <a:srcRect t="8169"/>
             <a:stretch>
               <a:fillRect/>
             </a:stretch>
           </p:blipFill>
           <p:spPr>
             <a:xfrm>
-              <a:off x="3345212" y="1363570"/>
-              <a:ext cx="5503333" cy="4127500"/>
+              <a:off x="3345212" y="1700766"/>
+              <a:ext cx="5503333" cy="3790303"/>
             </a:xfrm>
             <a:prstGeom prst="rect">
               <a:avLst/>

</xml_diff>